<commit_message>
fix: compiling issues,updated model
</commit_message>
<xml_diff>
--- a/presentation/siaga_nova_deck.pptx
+++ b/presentation/siaga_nova_deck.pptx
@@ -7214,7 +7214,7 @@
           <a:p>
             <a:pPr/>
             <a:r>
-              <a:t>1.12 years average error  |  R² 0.92 (2012-2014 held out)</a:t>
+              <a:t>1.08 years average error  |  R² 0.93 (2012-2014 held out)</a:t>
             </a:r>
           </a:p>
         </p:txBody>
@@ -7335,7 +7335,7 @@
           <a:p>
             <a:pPr/>
             <a:r>
-              <a:t>2.29 years average error  |  R² 0.69 (2015-2019, unseen source)</a:t>
+              <a:t>1.96 years average error  |  R² 0.76 (2015-2019, unseen source)</a:t>
             </a:r>
           </a:p>
         </p:txBody>

</xml_diff>